<commit_message>
Registra revisão da Entrega 2 antes da versão final
</commit_message>
<xml_diff>
--- a/entregas/02-entrevistas-e-mapa-de-empatia/Entrega_2_Collabora.AI_v2.pptx
+++ b/entregas/02-entrevistas-e-mapa-de-empatia/Entrega_2_Collabora.AI_v2.pptx
@@ -7388,7 +7388,7 @@
                 <a:cs typeface="Calibri"/>
                 <a:sym typeface="Calibri"/>
               </a:rPr>
-              <a:t>Campos: paráfrases. 'Precisa fazer' e insight: interpretações da equipe.</a:t>
+              <a:t>Relatos em paráfrase. Necessidade e insight: interpretações da equipe.</a:t>
             </a:r>
             <a:endParaRPr sz="1400" b="0" i="0" u="none" strike="noStrike" cap="none">
               <a:solidFill>
@@ -9326,7 +9326,7 @@
                 <a:cs typeface="Calibri"/>
                 <a:sym typeface="Calibri"/>
               </a:rPr>
-              <a:t>Acha que alternar contexto atrapalha o estudo.</a:t>
+              <a:t>Sente-se perdido e cansado ao mudar de contexto.</a:t>
             </a:r>
             <a:endParaRPr sz="1400" b="0" i="0" u="none" strike="noStrike" cap="none">
               <a:solidFill>
@@ -10036,7 +10036,7 @@
                 <a:cs typeface="Calibri"/>
                 <a:sym typeface="Calibri"/>
               </a:rPr>
-              <a:t>Campos: paráfrases. 'Precisa fazer' e insight: interpretações da equipe.</a:t>
+              <a:t>Relatos em paráfrase. Necessidade e insight: interpretações da equipe.</a:t>
             </a:r>
             <a:endParaRPr sz="1400" b="0" i="0" u="none" strike="noStrike" cap="none">
               <a:solidFill>
@@ -11790,7 +11790,7 @@
                 <a:cs typeface="Calibri"/>
                 <a:sym typeface="Calibri"/>
               </a:rPr>
-              <a:t>Não relatou comentários ou orientações recebidos.</a:t>
+              <a:t>Ouve que colegas acertam exercícios, mas depois esquecem como refazê-los.</a:t>
             </a:r>
             <a:endParaRPr sz="1400" b="0" i="0" u="none" strike="noStrike" cap="none">
               <a:solidFill>
@@ -12684,7 +12684,7 @@
                 <a:cs typeface="Calibri"/>
                 <a:sym typeface="Calibri"/>
               </a:rPr>
-              <a:t>Campos: paráfrases. 'Precisa fazer' e insight: interpretações da equipe.</a:t>
+              <a:t>Relatos em paráfrase. Necessidade e insight: interpretações da equipe.</a:t>
             </a:r>
             <a:endParaRPr sz="1400" b="0" i="0" u="none" strike="noStrike" cap="none">
               <a:solidFill>
@@ -21589,7 +21589,7 @@
                 <a:cs typeface="Calibri"/>
                 <a:sym typeface="Calibri"/>
               </a:rPr>
-              <a:t>Opiniões ou orientações não relatadas.</a:t>
+              <a:t>Ouve que colegas acertam exercícios, mas depois esquecem como refazê-los.</a:t>
             </a:r>
             <a:endParaRPr sz="1400" b="0" i="0" u="none" strike="noStrike" cap="none">
               <a:solidFill>
@@ -22483,7 +22483,7 @@
                 <a:cs typeface="Calibri"/>
                 <a:sym typeface="Calibri"/>
               </a:rPr>
-              <a:t>Campos: paráfrases. 'Precisa fazer' e insight: interpretações da equipe.</a:t>
+              <a:t>Relatos em paráfrase. Necessidade e insight: interpretações da equipe.</a:t>
             </a:r>
             <a:endParaRPr sz="1400" b="0" i="0" u="none" strike="noStrike" cap="none">
               <a:solidFill>
@@ -24192,7 +24192,7 @@
                 <a:cs typeface="Calibri"/>
                 <a:sym typeface="Calibri"/>
               </a:rPr>
-              <a:t>Grupo: E1/E2/E5. Matérias: E3. Tempo: E4.</a:t>
+              <a:t>E1: quer guardar dicas. E2: quer incluir mídia e contas. E5: falta material central.</a:t>
             </a:r>
             <a:endParaRPr sz="1400" b="0" i="0" u="none" strike="noStrike" cap="none">
               <a:solidFill>
@@ -24832,7 +24832,7 @@
                 <a:cs typeface="Calibri"/>
                 <a:sym typeface="Calibri"/>
               </a:rPr>
-              <a:t>Materiais: E1/E2/E5. Outras: E3/E4.</a:t>
+              <a:t>E1: dicas esquecidas. E2: Docs limita formatos. E5: materiais dispersos.</a:t>
             </a:r>
             <a:endParaRPr sz="1400" b="0" i="0" u="none" strike="noStrike" cap="none">
               <a:solidFill>
@@ -25472,7 +25472,7 @@
                 <a:cs typeface="Calibri"/>
                 <a:sym typeface="Calibri"/>
               </a:rPr>
-              <a:t>Grupo: E1/E2/E3/E5. Individual: E3/E4.</a:t>
+              <a:t>E1: listas em grupo. E2: resumos ao grupo. E3: estudo misto. E4: estuda só. E5: grupo.</a:t>
             </a:r>
             <a:endParaRPr sz="1400" b="0" i="0" u="none" strike="noStrike" cap="none">
               <a:solidFill>
@@ -26112,7 +26112,7 @@
                 <a:cs typeface="Calibri"/>
                 <a:sym typeface="Calibri"/>
               </a:rPr>
-              <a:t>E1, E2, E3, E5</a:t>
+              <a:t>E1: folhas soltas. E2: Docs. E3: veteranos. E5: cadernos, arquivos e mensagens.</a:t>
             </a:r>
             <a:endParaRPr sz="1400" b="0" i="0" u="none" strike="noStrike" cap="none">
               <a:solidFill>
@@ -26752,7 +26752,7 @@
                 <a:cs typeface="Calibri"/>
                 <a:sym typeface="Calibri"/>
               </a:rPr>
-              <a:t>E1, E3</a:t>
+              <a:t>E1: quer rever dicas para provas. E3: busca uso profissional das matérias.</a:t>
             </a:r>
             <a:endParaRPr sz="1400" b="0" i="0" u="none" strike="noStrike" cap="none">
               <a:solidFill>
@@ -26946,7 +26946,7 @@
                 <a:cs typeface="Calibri"/>
                 <a:sym typeface="Calibri"/>
               </a:rPr>
-              <a:t>Síntese qualitativa de E1–E5. As implicações são interpretações da equipe.</a:t>
+              <a:t>Padrões e implicações são interpretações da equipe apoiadas nos relatos E1–E5.</a:t>
             </a:r>
             <a:endParaRPr sz="1400" b="0" i="0" u="none" strike="noStrike" cap="none">
               <a:solidFill>
@@ -34934,7 +34934,7 @@
                 <a:cs typeface="Calibri"/>
                 <a:sym typeface="Calibri"/>
               </a:rPr>
-              <a:t>Acha o Docs limitado. Emoção não relatada.</a:t>
+              <a:t>Preparar resumos demora e a pessoa se sente cansada.</a:t>
             </a:r>
             <a:endParaRPr sz="1400" b="0" i="0" u="none" strike="noStrike" cap="none">
               <a:solidFill>
@@ -35644,7 +35644,7 @@
                 <a:cs typeface="Calibri"/>
                 <a:sym typeface="Calibri"/>
               </a:rPr>
-              <a:t>Campos: paráfrases. 'Precisa fazer' e insight: interpretações da equipe.</a:t>
+              <a:t>Relatos em paráfrase. Necessidade e insight: interpretações da equipe.</a:t>
             </a:r>
             <a:endParaRPr sz="1400" b="0" i="0" u="none" strike="noStrike" cap="none">
               <a:solidFill>

</xml_diff>